<commit_message>
Feat: Improved 2-column output, dropped slide "content"
</commit_message>
<xml_diff>
--- a/tests/data/two_content.pptx
+++ b/tests/data/two_content.pptx
@@ -5,8 +5,8 @@
     <p:sldMasterId id="2147483648" r:id="rId1"/>
   </p:sldMasterIdLst>
   <p:sldIdLst>
-    <p:sldId id="256" r:id="rId7"/>
-    <p:sldId id="257" r:id="rId8"/>
+    <p:sldId id="256" r:id="rId2"/>
+    <p:sldId id="257" r:id="rId3"/>
   </p:sldIdLst>
   <p:sldSz cx="9144000" cy="6858000" type="screen4x3"/>
   <p:notesSz cx="6858000" cy="9144000"/>
@@ -105,6 +105,22 @@
       </a:defRPr>
     </a:lvl9pPr>
   </p:defaultTextStyle>
+  <p:extLst>
+    <p:ext uri="{EFAFB233-063F-42B5-8137-9DF3F51BA10A}">
+      <p15:sldGuideLst xmlns:p15="http://schemas.microsoft.com/office/powerpoint/2012/main">
+        <p15:guide id="1" orient="horz" pos="2160">
+          <p15:clr>
+            <a:srgbClr val="A4A3A4"/>
+          </p15:clr>
+        </p15:guide>
+        <p15:guide id="2" pos="2880">
+          <p15:clr>
+            <a:srgbClr val="A4A3A4"/>
+          </p15:clr>
+        </p15:guide>
+      </p15:sldGuideLst>
+    </p:ext>
+  </p:extLst>
 </p:presentation>
 </file>
 
@@ -146,10 +162,9 @@
           <a:lstStyle/>
           <a:p>
             <a:r>
-              <a:rPr lang="en-US" smtClean="0"/>
+              <a:rPr lang="en-US"/>
               <a:t>Click to edit Master title style</a:t>
             </a:r>
-            <a:endParaRPr lang="en-US"/>
           </a:p>
         </p:txBody>
       </p:sp>
@@ -265,10 +280,9 @@
           </a:lstStyle>
           <a:p>
             <a:r>
-              <a:rPr lang="en-US" smtClean="0"/>
+              <a:rPr lang="en-US"/>
               <a:t>Click to edit Master subtitle style</a:t>
             </a:r>
-            <a:endParaRPr lang="en-US"/>
           </a:p>
         </p:txBody>
       </p:sp>
@@ -289,7 +303,7 @@
           <a:p>
             <a:fld id="{5BCAD085-E8A6-8845-BD4E-CB4CCA059FC4}" type="datetimeFigureOut">
               <a:rPr lang="en-US" smtClean="0"/>
-              <a:t>1/27/13</a:t>
+              <a:t>4/18/2026</a:t>
             </a:fld>
             <a:endParaRPr lang="en-US"/>
           </a:p>
@@ -331,7 +345,7 @@
           <a:p>
             <a:fld id="{C1FF6DA9-008F-8B48-92A6-B652298478BF}" type="slidenum">
               <a:rPr lang="en-US" smtClean="0"/>
-              <a:t>‹#›</a:t>
+              <a:t>‹Nr.›</a:t>
             </a:fld>
             <a:endParaRPr lang="en-US"/>
           </a:p>
@@ -383,10 +397,9 @@
           <a:lstStyle/>
           <a:p>
             <a:r>
-              <a:rPr lang="en-US" smtClean="0"/>
+              <a:rPr lang="en-US"/>
               <a:t>Click to edit Master title style</a:t>
             </a:r>
-            <a:endParaRPr lang="en-US"/>
           </a:p>
         </p:txBody>
       </p:sp>
@@ -407,38 +420,37 @@
           <a:p>
             <a:pPr lvl="0"/>
             <a:r>
-              <a:rPr lang="en-US" smtClean="0"/>
+              <a:rPr lang="en-US"/>
               <a:t>Click to edit Master text styles</a:t>
             </a:r>
           </a:p>
           <a:p>
             <a:pPr lvl="1"/>
             <a:r>
-              <a:rPr lang="en-US" smtClean="0"/>
+              <a:rPr lang="en-US"/>
               <a:t>Second level</a:t>
             </a:r>
           </a:p>
           <a:p>
             <a:pPr lvl="2"/>
             <a:r>
-              <a:rPr lang="en-US" smtClean="0"/>
+              <a:rPr lang="en-US"/>
               <a:t>Third level</a:t>
             </a:r>
           </a:p>
           <a:p>
             <a:pPr lvl="3"/>
             <a:r>
-              <a:rPr lang="en-US" smtClean="0"/>
+              <a:rPr lang="en-US"/>
               <a:t>Fourth level</a:t>
             </a:r>
           </a:p>
           <a:p>
             <a:pPr lvl="4"/>
             <a:r>
-              <a:rPr lang="en-US" smtClean="0"/>
+              <a:rPr lang="en-US"/>
               <a:t>Fifth level</a:t>
             </a:r>
-            <a:endParaRPr lang="en-US"/>
           </a:p>
         </p:txBody>
       </p:sp>
@@ -459,7 +471,7 @@
           <a:p>
             <a:fld id="{5BCAD085-E8A6-8845-BD4E-CB4CCA059FC4}" type="datetimeFigureOut">
               <a:rPr lang="en-US" smtClean="0"/>
-              <a:t>1/27/13</a:t>
+              <a:t>4/18/2026</a:t>
             </a:fld>
             <a:endParaRPr lang="en-US"/>
           </a:p>
@@ -501,7 +513,7 @@
           <a:p>
             <a:fld id="{C1FF6DA9-008F-8B48-92A6-B652298478BF}" type="slidenum">
               <a:rPr lang="en-US" smtClean="0"/>
-              <a:t>‹#›</a:t>
+              <a:t>‹Nr.›</a:t>
             </a:fld>
             <a:endParaRPr lang="en-US"/>
           </a:p>
@@ -558,10 +570,9 @@
           <a:lstStyle/>
           <a:p>
             <a:r>
-              <a:rPr lang="en-US" smtClean="0"/>
+              <a:rPr lang="en-US"/>
               <a:t>Click to edit Master title style</a:t>
             </a:r>
-            <a:endParaRPr lang="en-US"/>
           </a:p>
         </p:txBody>
       </p:sp>
@@ -587,38 +598,37 @@
           <a:p>
             <a:pPr lvl="0"/>
             <a:r>
-              <a:rPr lang="en-US" smtClean="0"/>
+              <a:rPr lang="en-US"/>
               <a:t>Click to edit Master text styles</a:t>
             </a:r>
           </a:p>
           <a:p>
             <a:pPr lvl="1"/>
             <a:r>
-              <a:rPr lang="en-US" smtClean="0"/>
+              <a:rPr lang="en-US"/>
               <a:t>Second level</a:t>
             </a:r>
           </a:p>
           <a:p>
             <a:pPr lvl="2"/>
             <a:r>
-              <a:rPr lang="en-US" smtClean="0"/>
+              <a:rPr lang="en-US"/>
               <a:t>Third level</a:t>
             </a:r>
           </a:p>
           <a:p>
             <a:pPr lvl="3"/>
             <a:r>
-              <a:rPr lang="en-US" smtClean="0"/>
+              <a:rPr lang="en-US"/>
               <a:t>Fourth level</a:t>
             </a:r>
           </a:p>
           <a:p>
             <a:pPr lvl="4"/>
             <a:r>
-              <a:rPr lang="en-US" smtClean="0"/>
+              <a:rPr lang="en-US"/>
               <a:t>Fifth level</a:t>
             </a:r>
-            <a:endParaRPr lang="en-US"/>
           </a:p>
         </p:txBody>
       </p:sp>
@@ -639,7 +649,7 @@
           <a:p>
             <a:fld id="{5BCAD085-E8A6-8845-BD4E-CB4CCA059FC4}" type="datetimeFigureOut">
               <a:rPr lang="en-US" smtClean="0"/>
-              <a:t>1/27/13</a:t>
+              <a:t>4/18/2026</a:t>
             </a:fld>
             <a:endParaRPr lang="en-US"/>
           </a:p>
@@ -681,7 +691,7 @@
           <a:p>
             <a:fld id="{C1FF6DA9-008F-8B48-92A6-B652298478BF}" type="slidenum">
               <a:rPr lang="en-US" smtClean="0"/>
-              <a:t>‹#›</a:t>
+              <a:t>‹Nr.›</a:t>
             </a:fld>
             <a:endParaRPr lang="en-US"/>
           </a:p>
@@ -733,10 +743,9 @@
           <a:lstStyle/>
           <a:p>
             <a:r>
-              <a:rPr lang="en-US" smtClean="0"/>
+              <a:rPr lang="en-US"/>
               <a:t>Click to edit Master title style</a:t>
             </a:r>
-            <a:endParaRPr lang="en-US"/>
           </a:p>
         </p:txBody>
       </p:sp>
@@ -757,38 +766,37 @@
           <a:p>
             <a:pPr lvl="0"/>
             <a:r>
-              <a:rPr lang="en-US" smtClean="0"/>
+              <a:rPr lang="en-US"/>
               <a:t>Click to edit Master text styles</a:t>
             </a:r>
           </a:p>
           <a:p>
             <a:pPr lvl="1"/>
             <a:r>
-              <a:rPr lang="en-US" smtClean="0"/>
+              <a:rPr lang="en-US"/>
               <a:t>Second level</a:t>
             </a:r>
           </a:p>
           <a:p>
             <a:pPr lvl="2"/>
             <a:r>
-              <a:rPr lang="en-US" smtClean="0"/>
+              <a:rPr lang="en-US"/>
               <a:t>Third level</a:t>
             </a:r>
           </a:p>
           <a:p>
             <a:pPr lvl="3"/>
             <a:r>
-              <a:rPr lang="en-US" smtClean="0"/>
+              <a:rPr lang="en-US"/>
               <a:t>Fourth level</a:t>
             </a:r>
           </a:p>
           <a:p>
             <a:pPr lvl="4"/>
             <a:r>
-              <a:rPr lang="en-US" smtClean="0"/>
+              <a:rPr lang="en-US"/>
               <a:t>Fifth level</a:t>
             </a:r>
-            <a:endParaRPr lang="en-US"/>
           </a:p>
         </p:txBody>
       </p:sp>
@@ -809,7 +817,7 @@
           <a:p>
             <a:fld id="{5BCAD085-E8A6-8845-BD4E-CB4CCA059FC4}" type="datetimeFigureOut">
               <a:rPr lang="en-US" smtClean="0"/>
-              <a:t>1/27/13</a:t>
+              <a:t>4/18/2026</a:t>
             </a:fld>
             <a:endParaRPr lang="en-US"/>
           </a:p>
@@ -851,7 +859,7 @@
           <a:p>
             <a:fld id="{C1FF6DA9-008F-8B48-92A6-B652298478BF}" type="slidenum">
               <a:rPr lang="en-US" smtClean="0"/>
-              <a:t>‹#›</a:t>
+              <a:t>‹Nr.›</a:t>
             </a:fld>
             <a:endParaRPr lang="en-US"/>
           </a:p>
@@ -912,10 +920,9 @@
           </a:lstStyle>
           <a:p>
             <a:r>
-              <a:rPr lang="en-US" smtClean="0"/>
+              <a:rPr lang="en-US"/>
               <a:t>Click to edit Master title style</a:t>
             </a:r>
-            <a:endParaRPr lang="en-US"/>
           </a:p>
         </p:txBody>
       </p:sp>
@@ -1032,7 +1039,7 @@
           <a:p>
             <a:pPr lvl="0"/>
             <a:r>
-              <a:rPr lang="en-US" smtClean="0"/>
+              <a:rPr lang="en-US"/>
               <a:t>Click to edit Master text styles</a:t>
             </a:r>
           </a:p>
@@ -1055,7 +1062,7 @@
           <a:p>
             <a:fld id="{5BCAD085-E8A6-8845-BD4E-CB4CCA059FC4}" type="datetimeFigureOut">
               <a:rPr lang="en-US" smtClean="0"/>
-              <a:t>1/27/13</a:t>
+              <a:t>4/18/2026</a:t>
             </a:fld>
             <a:endParaRPr lang="en-US"/>
           </a:p>
@@ -1097,7 +1104,7 @@
           <a:p>
             <a:fld id="{C1FF6DA9-008F-8B48-92A6-B652298478BF}" type="slidenum">
               <a:rPr lang="en-US" smtClean="0"/>
-              <a:t>‹#›</a:t>
+              <a:t>‹Nr.›</a:t>
             </a:fld>
             <a:endParaRPr lang="en-US"/>
           </a:p>
@@ -1149,10 +1156,9 @@
           <a:lstStyle/>
           <a:p>
             <a:r>
-              <a:rPr lang="en-US" smtClean="0"/>
+              <a:rPr lang="en-US"/>
               <a:t>Click to edit Master title style</a:t>
             </a:r>
-            <a:endParaRPr lang="en-US"/>
           </a:p>
         </p:txBody>
       </p:sp>
@@ -1206,38 +1212,37 @@
           <a:p>
             <a:pPr lvl="0"/>
             <a:r>
-              <a:rPr lang="en-US" smtClean="0"/>
+              <a:rPr lang="en-US"/>
               <a:t>Click to edit Master text styles</a:t>
             </a:r>
           </a:p>
           <a:p>
             <a:pPr lvl="1"/>
             <a:r>
-              <a:rPr lang="en-US" smtClean="0"/>
+              <a:rPr lang="en-US"/>
               <a:t>Second level</a:t>
             </a:r>
           </a:p>
           <a:p>
             <a:pPr lvl="2"/>
             <a:r>
-              <a:rPr lang="en-US" smtClean="0"/>
+              <a:rPr lang="en-US"/>
               <a:t>Third level</a:t>
             </a:r>
           </a:p>
           <a:p>
             <a:pPr lvl="3"/>
             <a:r>
-              <a:rPr lang="en-US" smtClean="0"/>
+              <a:rPr lang="en-US"/>
               <a:t>Fourth level</a:t>
             </a:r>
           </a:p>
           <a:p>
             <a:pPr lvl="4"/>
             <a:r>
-              <a:rPr lang="en-US" smtClean="0"/>
+              <a:rPr lang="en-US"/>
               <a:t>Fifth level</a:t>
             </a:r>
-            <a:endParaRPr lang="en-US"/>
           </a:p>
         </p:txBody>
       </p:sp>
@@ -1291,38 +1296,37 @@
           <a:p>
             <a:pPr lvl="0"/>
             <a:r>
-              <a:rPr lang="en-US" smtClean="0"/>
+              <a:rPr lang="en-US"/>
               <a:t>Click to edit Master text styles</a:t>
             </a:r>
           </a:p>
           <a:p>
             <a:pPr lvl="1"/>
             <a:r>
-              <a:rPr lang="en-US" smtClean="0"/>
+              <a:rPr lang="en-US"/>
               <a:t>Second level</a:t>
             </a:r>
           </a:p>
           <a:p>
             <a:pPr lvl="2"/>
             <a:r>
-              <a:rPr lang="en-US" smtClean="0"/>
+              <a:rPr lang="en-US"/>
               <a:t>Third level</a:t>
             </a:r>
           </a:p>
           <a:p>
             <a:pPr lvl="3"/>
             <a:r>
-              <a:rPr lang="en-US" smtClean="0"/>
+              <a:rPr lang="en-US"/>
               <a:t>Fourth level</a:t>
             </a:r>
           </a:p>
           <a:p>
             <a:pPr lvl="4"/>
             <a:r>
-              <a:rPr lang="en-US" smtClean="0"/>
+              <a:rPr lang="en-US"/>
               <a:t>Fifth level</a:t>
             </a:r>
-            <a:endParaRPr lang="en-US"/>
           </a:p>
         </p:txBody>
       </p:sp>
@@ -1343,7 +1347,7 @@
           <a:p>
             <a:fld id="{5BCAD085-E8A6-8845-BD4E-CB4CCA059FC4}" type="datetimeFigureOut">
               <a:rPr lang="en-US" smtClean="0"/>
-              <a:t>1/27/13</a:t>
+              <a:t>4/18/2026</a:t>
             </a:fld>
             <a:endParaRPr lang="en-US"/>
           </a:p>
@@ -1385,7 +1389,7 @@
           <a:p>
             <a:fld id="{C1FF6DA9-008F-8B48-92A6-B652298478BF}" type="slidenum">
               <a:rPr lang="en-US" smtClean="0"/>
-              <a:t>‹#›</a:t>
+              <a:t>‹Nr.›</a:t>
             </a:fld>
             <a:endParaRPr lang="en-US"/>
           </a:p>
@@ -1441,10 +1445,9 @@
           </a:lstStyle>
           <a:p>
             <a:r>
-              <a:rPr lang="en-US" smtClean="0"/>
+              <a:rPr lang="en-US"/>
               <a:t>Click to edit Master title style</a:t>
             </a:r>
-            <a:endParaRPr lang="en-US"/>
           </a:p>
         </p:txBody>
       </p:sp>
@@ -1507,7 +1510,7 @@
           <a:p>
             <a:pPr lvl="0"/>
             <a:r>
-              <a:rPr lang="en-US" smtClean="0"/>
+              <a:rPr lang="en-US"/>
               <a:t>Click to edit Master text styles</a:t>
             </a:r>
           </a:p>
@@ -1563,38 +1566,37 @@
           <a:p>
             <a:pPr lvl="0"/>
             <a:r>
-              <a:rPr lang="en-US" smtClean="0"/>
+              <a:rPr lang="en-US"/>
               <a:t>Click to edit Master text styles</a:t>
             </a:r>
           </a:p>
           <a:p>
             <a:pPr lvl="1"/>
             <a:r>
-              <a:rPr lang="en-US" smtClean="0"/>
+              <a:rPr lang="en-US"/>
               <a:t>Second level</a:t>
             </a:r>
           </a:p>
           <a:p>
             <a:pPr lvl="2"/>
             <a:r>
-              <a:rPr lang="en-US" smtClean="0"/>
+              <a:rPr lang="en-US"/>
               <a:t>Third level</a:t>
             </a:r>
           </a:p>
           <a:p>
             <a:pPr lvl="3"/>
             <a:r>
-              <a:rPr lang="en-US" smtClean="0"/>
+              <a:rPr lang="en-US"/>
               <a:t>Fourth level</a:t>
             </a:r>
           </a:p>
           <a:p>
             <a:pPr lvl="4"/>
             <a:r>
-              <a:rPr lang="en-US" smtClean="0"/>
+              <a:rPr lang="en-US"/>
               <a:t>Fifth level</a:t>
             </a:r>
-            <a:endParaRPr lang="en-US"/>
           </a:p>
         </p:txBody>
       </p:sp>
@@ -1657,7 +1659,7 @@
           <a:p>
             <a:pPr lvl="0"/>
             <a:r>
-              <a:rPr lang="en-US" smtClean="0"/>
+              <a:rPr lang="en-US"/>
               <a:t>Click to edit Master text styles</a:t>
             </a:r>
           </a:p>
@@ -1713,38 +1715,37 @@
           <a:p>
             <a:pPr lvl="0"/>
             <a:r>
-              <a:rPr lang="en-US" smtClean="0"/>
+              <a:rPr lang="en-US"/>
               <a:t>Click to edit Master text styles</a:t>
             </a:r>
           </a:p>
           <a:p>
             <a:pPr lvl="1"/>
             <a:r>
-              <a:rPr lang="en-US" smtClean="0"/>
+              <a:rPr lang="en-US"/>
               <a:t>Second level</a:t>
             </a:r>
           </a:p>
           <a:p>
             <a:pPr lvl="2"/>
             <a:r>
-              <a:rPr lang="en-US" smtClean="0"/>
+              <a:rPr lang="en-US"/>
               <a:t>Third level</a:t>
             </a:r>
           </a:p>
           <a:p>
             <a:pPr lvl="3"/>
             <a:r>
-              <a:rPr lang="en-US" smtClean="0"/>
+              <a:rPr lang="en-US"/>
               <a:t>Fourth level</a:t>
             </a:r>
           </a:p>
           <a:p>
             <a:pPr lvl="4"/>
             <a:r>
-              <a:rPr lang="en-US" smtClean="0"/>
+              <a:rPr lang="en-US"/>
               <a:t>Fifth level</a:t>
             </a:r>
-            <a:endParaRPr lang="en-US"/>
           </a:p>
         </p:txBody>
       </p:sp>
@@ -1765,7 +1766,7 @@
           <a:p>
             <a:fld id="{5BCAD085-E8A6-8845-BD4E-CB4CCA059FC4}" type="datetimeFigureOut">
               <a:rPr lang="en-US" smtClean="0"/>
-              <a:t>1/27/13</a:t>
+              <a:t>4/18/2026</a:t>
             </a:fld>
             <a:endParaRPr lang="en-US"/>
           </a:p>
@@ -1807,7 +1808,7 @@
           <a:p>
             <a:fld id="{C1FF6DA9-008F-8B48-92A6-B652298478BF}" type="slidenum">
               <a:rPr lang="en-US" smtClean="0"/>
-              <a:t>‹#›</a:t>
+              <a:t>‹Nr.›</a:t>
             </a:fld>
             <a:endParaRPr lang="en-US"/>
           </a:p>
@@ -1859,10 +1860,9 @@
           <a:lstStyle/>
           <a:p>
             <a:r>
-              <a:rPr lang="en-US" smtClean="0"/>
+              <a:rPr lang="en-US"/>
               <a:t>Click to edit Master title style</a:t>
             </a:r>
-            <a:endParaRPr lang="en-US"/>
           </a:p>
         </p:txBody>
       </p:sp>
@@ -1883,7 +1883,7 @@
           <a:p>
             <a:fld id="{5BCAD085-E8A6-8845-BD4E-CB4CCA059FC4}" type="datetimeFigureOut">
               <a:rPr lang="en-US" smtClean="0"/>
-              <a:t>1/27/13</a:t>
+              <a:t>4/18/2026</a:t>
             </a:fld>
             <a:endParaRPr lang="en-US"/>
           </a:p>
@@ -1925,7 +1925,7 @@
           <a:p>
             <a:fld id="{C1FF6DA9-008F-8B48-92A6-B652298478BF}" type="slidenum">
               <a:rPr lang="en-US" smtClean="0"/>
-              <a:t>‹#›</a:t>
+              <a:t>‹Nr.›</a:t>
             </a:fld>
             <a:endParaRPr lang="en-US"/>
           </a:p>
@@ -1978,7 +1978,7 @@
           <a:p>
             <a:fld id="{5BCAD085-E8A6-8845-BD4E-CB4CCA059FC4}" type="datetimeFigureOut">
               <a:rPr lang="en-US" smtClean="0"/>
-              <a:t>1/27/13</a:t>
+              <a:t>4/18/2026</a:t>
             </a:fld>
             <a:endParaRPr lang="en-US"/>
           </a:p>
@@ -2020,7 +2020,7 @@
           <a:p>
             <a:fld id="{C1FF6DA9-008F-8B48-92A6-B652298478BF}" type="slidenum">
               <a:rPr lang="en-US" smtClean="0"/>
-              <a:t>‹#›</a:t>
+              <a:t>‹Nr.›</a:t>
             </a:fld>
             <a:endParaRPr lang="en-US"/>
           </a:p>
@@ -2081,10 +2081,9 @@
           </a:lstStyle>
           <a:p>
             <a:r>
-              <a:rPr lang="en-US" smtClean="0"/>
+              <a:rPr lang="en-US"/>
               <a:t>Click to edit Master title style</a:t>
             </a:r>
-            <a:endParaRPr lang="en-US"/>
           </a:p>
         </p:txBody>
       </p:sp>
@@ -2138,38 +2137,37 @@
           <a:p>
             <a:pPr lvl="0"/>
             <a:r>
-              <a:rPr lang="en-US" smtClean="0"/>
+              <a:rPr lang="en-US"/>
               <a:t>Click to edit Master text styles</a:t>
             </a:r>
           </a:p>
           <a:p>
             <a:pPr lvl="1"/>
             <a:r>
-              <a:rPr lang="en-US" smtClean="0"/>
+              <a:rPr lang="en-US"/>
               <a:t>Second level</a:t>
             </a:r>
           </a:p>
           <a:p>
             <a:pPr lvl="2"/>
             <a:r>
-              <a:rPr lang="en-US" smtClean="0"/>
+              <a:rPr lang="en-US"/>
               <a:t>Third level</a:t>
             </a:r>
           </a:p>
           <a:p>
             <a:pPr lvl="3"/>
             <a:r>
-              <a:rPr lang="en-US" smtClean="0"/>
+              <a:rPr lang="en-US"/>
               <a:t>Fourth level</a:t>
             </a:r>
           </a:p>
           <a:p>
             <a:pPr lvl="4"/>
             <a:r>
-              <a:rPr lang="en-US" smtClean="0"/>
+              <a:rPr lang="en-US"/>
               <a:t>Fifth level</a:t>
             </a:r>
-            <a:endParaRPr lang="en-US"/>
           </a:p>
         </p:txBody>
       </p:sp>
@@ -2232,7 +2230,7 @@
           <a:p>
             <a:pPr lvl="0"/>
             <a:r>
-              <a:rPr lang="en-US" smtClean="0"/>
+              <a:rPr lang="en-US"/>
               <a:t>Click to edit Master text styles</a:t>
             </a:r>
           </a:p>
@@ -2255,7 +2253,7 @@
           <a:p>
             <a:fld id="{5BCAD085-E8A6-8845-BD4E-CB4CCA059FC4}" type="datetimeFigureOut">
               <a:rPr lang="en-US" smtClean="0"/>
-              <a:t>1/27/13</a:t>
+              <a:t>4/18/2026</a:t>
             </a:fld>
             <a:endParaRPr lang="en-US"/>
           </a:p>
@@ -2297,7 +2295,7 @@
           <a:p>
             <a:fld id="{C1FF6DA9-008F-8B48-92A6-B652298478BF}" type="slidenum">
               <a:rPr lang="en-US" smtClean="0"/>
-              <a:t>‹#›</a:t>
+              <a:t>‹Nr.›</a:t>
             </a:fld>
             <a:endParaRPr lang="en-US"/>
           </a:p>
@@ -2358,10 +2356,9 @@
           </a:lstStyle>
           <a:p>
             <a:r>
-              <a:rPr lang="en-US" smtClean="0"/>
+              <a:rPr lang="en-US"/>
               <a:t>Click to edit Master title style</a:t>
             </a:r>
-            <a:endParaRPr lang="en-US"/>
           </a:p>
         </p:txBody>
       </p:sp>
@@ -2485,7 +2482,7 @@
           <a:p>
             <a:pPr lvl="0"/>
             <a:r>
-              <a:rPr lang="en-US" smtClean="0"/>
+              <a:rPr lang="en-US"/>
               <a:t>Click to edit Master text styles</a:t>
             </a:r>
           </a:p>
@@ -2508,7 +2505,7 @@
           <a:p>
             <a:fld id="{5BCAD085-E8A6-8845-BD4E-CB4CCA059FC4}" type="datetimeFigureOut">
               <a:rPr lang="en-US" smtClean="0"/>
-              <a:t>1/27/13</a:t>
+              <a:t>4/18/2026</a:t>
             </a:fld>
             <a:endParaRPr lang="en-US"/>
           </a:p>
@@ -2550,7 +2547,7 @@
           <a:p>
             <a:fld id="{C1FF6DA9-008F-8B48-92A6-B652298478BF}" type="slidenum">
               <a:rPr lang="en-US" smtClean="0"/>
-              <a:t>‹#›</a:t>
+              <a:t>‹Nr.›</a:t>
             </a:fld>
             <a:endParaRPr lang="en-US"/>
           </a:p>
@@ -2617,10 +2614,9 @@
           <a:lstStyle/>
           <a:p>
             <a:r>
-              <a:rPr lang="en-US" smtClean="0"/>
+              <a:rPr lang="en-US"/>
               <a:t>Click to edit Master title style</a:t>
             </a:r>
-            <a:endParaRPr lang="en-US"/>
           </a:p>
         </p:txBody>
       </p:sp>
@@ -2651,38 +2647,37 @@
           <a:p>
             <a:pPr lvl="0"/>
             <a:r>
-              <a:rPr lang="en-US" smtClean="0"/>
+              <a:rPr lang="en-US"/>
               <a:t>Click to edit Master text styles</a:t>
             </a:r>
           </a:p>
           <a:p>
             <a:pPr lvl="1"/>
             <a:r>
-              <a:rPr lang="en-US" smtClean="0"/>
+              <a:rPr lang="en-US"/>
               <a:t>Second level</a:t>
             </a:r>
           </a:p>
           <a:p>
             <a:pPr lvl="2"/>
             <a:r>
-              <a:rPr lang="en-US" smtClean="0"/>
+              <a:rPr lang="en-US"/>
               <a:t>Third level</a:t>
             </a:r>
           </a:p>
           <a:p>
             <a:pPr lvl="3"/>
             <a:r>
-              <a:rPr lang="en-US" smtClean="0"/>
+              <a:rPr lang="en-US"/>
               <a:t>Fourth level</a:t>
             </a:r>
           </a:p>
           <a:p>
             <a:pPr lvl="4"/>
             <a:r>
-              <a:rPr lang="en-US" smtClean="0"/>
+              <a:rPr lang="en-US"/>
               <a:t>Fifth level</a:t>
             </a:r>
-            <a:endParaRPr lang="en-US"/>
           </a:p>
         </p:txBody>
       </p:sp>
@@ -2721,7 +2716,7 @@
           <a:p>
             <a:fld id="{5BCAD085-E8A6-8845-BD4E-CB4CCA059FC4}" type="datetimeFigureOut">
               <a:rPr lang="en-US" smtClean="0"/>
-              <a:t>1/27/13</a:t>
+              <a:t>4/18/2026</a:t>
             </a:fld>
             <a:endParaRPr lang="en-US"/>
           </a:p>
@@ -2799,7 +2794,7 @@
           <a:p>
             <a:fld id="{C1FF6DA9-008F-8B48-92A6-B652298478BF}" type="slidenum">
               <a:rPr lang="en-US" smtClean="0"/>
-              <a:t>‹#›</a:t>
+              <a:t>‹Nr.›</a:t>
             </a:fld>
             <a:endParaRPr lang="en-US"/>
           </a:p>
@@ -3080,7 +3075,7 @@
 </file>
 
 <file path=ppt/slides/slide1.xml><?xml version="1.0" encoding="utf-8"?>
-<p:sld xmlns:a="http://schemas.openxmlformats.org/drawingml/2006/main" xmlns:p="http://schemas.openxmlformats.org/presentationml/2006/main" xmlns:r="http://schemas.openxmlformats.org/officeDocument/2006/relationships">
+<p:sld xmlns:a="http://schemas.openxmlformats.org/drawingml/2006/main" xmlns:r="http://schemas.openxmlformats.org/officeDocument/2006/relationships" xmlns:p="http://schemas.openxmlformats.org/presentationml/2006/main">
   <p:cSld>
     <p:spTree>
       <p:nvGrpSpPr>
@@ -3088,7 +3083,14 @@
         <p:cNvGrpSpPr/>
         <p:nvPr/>
       </p:nvGrpSpPr>
-      <p:grpSpPr/>
+      <p:grpSpPr>
+        <a:xfrm>
+          <a:off x="0" y="0"/>
+          <a:ext cx="0" cy="0"/>
+          <a:chOff x="0" y="0"/>
+          <a:chExt cx="0" cy="0"/>
+        </a:xfrm>
+      </p:grpSpPr>
       <p:sp>
         <p:nvSpPr>
           <p:cNvPr id="2" name="Title 1"/>
@@ -3103,7 +3105,25 @@
         <p:txBody>
           <a:bodyPr/>
           <a:lstStyle/>
-          <a:p/>
+          <a:p>
+            <a:r>
+              <a:rPr lang="de-DE" dirty="0"/>
+              <a:t>Title </a:t>
+            </a:r>
+            <a:r>
+              <a:rPr lang="de-DE" dirty="0" err="1"/>
+              <a:t>of</a:t>
+            </a:r>
+            <a:r>
+              <a:rPr lang="de-DE" dirty="0"/>
+              <a:t> a Demo </a:t>
+            </a:r>
+            <a:r>
+              <a:rPr lang="de-DE" dirty="0" err="1"/>
+              <a:t>Presentation</a:t>
+            </a:r>
+            <a:endParaRPr dirty="0"/>
+          </a:p>
         </p:txBody>
       </p:sp>
       <p:sp>
@@ -3120,7 +3140,17 @@
         <p:txBody>
           <a:bodyPr/>
           <a:lstStyle/>
-          <a:p/>
+          <a:p>
+            <a:r>
+              <a:rPr lang="en-US" dirty="0"/>
+              <a:t>Author, Date</a:t>
+            </a:r>
+            <a:r>
+              <a:rPr lang="en-US"/>
+              <a:t>, Institution</a:t>
+            </a:r>
+            <a:endParaRPr lang="en-US" dirty="0"/>
+          </a:p>
         </p:txBody>
       </p:sp>
     </p:spTree>
@@ -3132,7 +3162,7 @@
 </file>
 
 <file path=ppt/slides/slide2.xml><?xml version="1.0" encoding="utf-8"?>
-<p:sld xmlns:a="http://schemas.openxmlformats.org/drawingml/2006/main" xmlns:p="http://schemas.openxmlformats.org/presentationml/2006/main" xmlns:r="http://schemas.openxmlformats.org/officeDocument/2006/relationships">
+<p:sld xmlns:a="http://schemas.openxmlformats.org/drawingml/2006/main" xmlns:r="http://schemas.openxmlformats.org/officeDocument/2006/relationships" xmlns:p="http://schemas.openxmlformats.org/presentationml/2006/main">
   <p:cSld>
     <p:spTree>
       <p:nvGrpSpPr>
@@ -3140,7 +3170,14 @@
         <p:cNvGrpSpPr/>
         <p:nvPr/>
       </p:nvGrpSpPr>
-      <p:grpSpPr/>
+      <p:grpSpPr>
+        <a:xfrm>
+          <a:off x="0" y="0"/>
+          <a:ext cx="0" cy="0"/>
+          <a:chOff x="0" y="0"/>
+          <a:chExt cx="0" cy="0"/>
+        </a:xfrm>
+      </p:grpSpPr>
       <p:sp>
         <p:nvSpPr>
           <p:cNvPr id="2" name="Title 1"/>
@@ -3169,7 +3206,7 @@
             <a:spLocks noGrp="1"/>
           </p:cNvSpPr>
           <p:nvPr>
-            <p:ph idx="1" sz="half"/>
+            <p:ph sz="half" idx="1"/>
           </p:nvPr>
         </p:nvSpPr>
         <p:spPr/>
@@ -3190,7 +3227,7 @@
             <a:spLocks noGrp="1"/>
           </p:cNvSpPr>
           <p:nvPr>
-            <p:ph idx="2" sz="half"/>
+            <p:ph sz="half" idx="2"/>
           </p:nvPr>
         </p:nvSpPr>
         <p:spPr/>

</xml_diff>

<commit_message>
Test: Added pptx data for complex layouts
</commit_message>
<xml_diff>
--- a/tests/data/two_content.pptx
+++ b/tests/data/two_content.pptx
@@ -5,8 +5,8 @@
     <p:sldMasterId id="2147483648" r:id="rId1"/>
   </p:sldMasterIdLst>
   <p:sldIdLst>
-    <p:sldId id="256" r:id="rId2"/>
-    <p:sldId id="257" r:id="rId3"/>
+    <p:sldId id="256" r:id="rId7"/>
+    <p:sldId id="257" r:id="rId8"/>
   </p:sldIdLst>
   <p:sldSz cx="9144000" cy="6858000" type="screen4x3"/>
   <p:notesSz cx="6858000" cy="9144000"/>
@@ -105,22 +105,6 @@
       </a:defRPr>
     </a:lvl9pPr>
   </p:defaultTextStyle>
-  <p:extLst>
-    <p:ext uri="{EFAFB233-063F-42B5-8137-9DF3F51BA10A}">
-      <p15:sldGuideLst xmlns:p15="http://schemas.microsoft.com/office/powerpoint/2012/main">
-        <p15:guide id="1" orient="horz" pos="2160">
-          <p15:clr>
-            <a:srgbClr val="A4A3A4"/>
-          </p15:clr>
-        </p15:guide>
-        <p15:guide id="2" pos="2880">
-          <p15:clr>
-            <a:srgbClr val="A4A3A4"/>
-          </p15:clr>
-        </p15:guide>
-      </p15:sldGuideLst>
-    </p:ext>
-  </p:extLst>
 </p:presentation>
 </file>
 
@@ -162,9 +146,10 @@
           <a:lstStyle/>
           <a:p>
             <a:r>
-              <a:rPr lang="en-US"/>
+              <a:rPr lang="en-US" smtClean="0"/>
               <a:t>Click to edit Master title style</a:t>
             </a:r>
+            <a:endParaRPr lang="en-US"/>
           </a:p>
         </p:txBody>
       </p:sp>
@@ -280,9 +265,10 @@
           </a:lstStyle>
           <a:p>
             <a:r>
-              <a:rPr lang="en-US"/>
+              <a:rPr lang="en-US" smtClean="0"/>
               <a:t>Click to edit Master subtitle style</a:t>
             </a:r>
+            <a:endParaRPr lang="en-US"/>
           </a:p>
         </p:txBody>
       </p:sp>
@@ -303,7 +289,7 @@
           <a:p>
             <a:fld id="{5BCAD085-E8A6-8845-BD4E-CB4CCA059FC4}" type="datetimeFigureOut">
               <a:rPr lang="en-US" smtClean="0"/>
-              <a:t>4/18/2026</a:t>
+              <a:t>1/27/13</a:t>
             </a:fld>
             <a:endParaRPr lang="en-US"/>
           </a:p>
@@ -345,7 +331,7 @@
           <a:p>
             <a:fld id="{C1FF6DA9-008F-8B48-92A6-B652298478BF}" type="slidenum">
               <a:rPr lang="en-US" smtClean="0"/>
-              <a:t>‹Nr.›</a:t>
+              <a:t>‹#›</a:t>
             </a:fld>
             <a:endParaRPr lang="en-US"/>
           </a:p>
@@ -397,9 +383,10 @@
           <a:lstStyle/>
           <a:p>
             <a:r>
-              <a:rPr lang="en-US"/>
+              <a:rPr lang="en-US" smtClean="0"/>
               <a:t>Click to edit Master title style</a:t>
             </a:r>
+            <a:endParaRPr lang="en-US"/>
           </a:p>
         </p:txBody>
       </p:sp>
@@ -420,37 +407,38 @@
           <a:p>
             <a:pPr lvl="0"/>
             <a:r>
-              <a:rPr lang="en-US"/>
+              <a:rPr lang="en-US" smtClean="0"/>
               <a:t>Click to edit Master text styles</a:t>
             </a:r>
           </a:p>
           <a:p>
             <a:pPr lvl="1"/>
             <a:r>
-              <a:rPr lang="en-US"/>
+              <a:rPr lang="en-US" smtClean="0"/>
               <a:t>Second level</a:t>
             </a:r>
           </a:p>
           <a:p>
             <a:pPr lvl="2"/>
             <a:r>
-              <a:rPr lang="en-US"/>
+              <a:rPr lang="en-US" smtClean="0"/>
               <a:t>Third level</a:t>
             </a:r>
           </a:p>
           <a:p>
             <a:pPr lvl="3"/>
             <a:r>
-              <a:rPr lang="en-US"/>
+              <a:rPr lang="en-US" smtClean="0"/>
               <a:t>Fourth level</a:t>
             </a:r>
           </a:p>
           <a:p>
             <a:pPr lvl="4"/>
             <a:r>
-              <a:rPr lang="en-US"/>
+              <a:rPr lang="en-US" smtClean="0"/>
               <a:t>Fifth level</a:t>
             </a:r>
+            <a:endParaRPr lang="en-US"/>
           </a:p>
         </p:txBody>
       </p:sp>
@@ -471,7 +459,7 @@
           <a:p>
             <a:fld id="{5BCAD085-E8A6-8845-BD4E-CB4CCA059FC4}" type="datetimeFigureOut">
               <a:rPr lang="en-US" smtClean="0"/>
-              <a:t>4/18/2026</a:t>
+              <a:t>1/27/13</a:t>
             </a:fld>
             <a:endParaRPr lang="en-US"/>
           </a:p>
@@ -513,7 +501,7 @@
           <a:p>
             <a:fld id="{C1FF6DA9-008F-8B48-92A6-B652298478BF}" type="slidenum">
               <a:rPr lang="en-US" smtClean="0"/>
-              <a:t>‹Nr.›</a:t>
+              <a:t>‹#›</a:t>
             </a:fld>
             <a:endParaRPr lang="en-US"/>
           </a:p>
@@ -570,9 +558,10 @@
           <a:lstStyle/>
           <a:p>
             <a:r>
-              <a:rPr lang="en-US"/>
+              <a:rPr lang="en-US" smtClean="0"/>
               <a:t>Click to edit Master title style</a:t>
             </a:r>
+            <a:endParaRPr lang="en-US"/>
           </a:p>
         </p:txBody>
       </p:sp>
@@ -598,37 +587,38 @@
           <a:p>
             <a:pPr lvl="0"/>
             <a:r>
-              <a:rPr lang="en-US"/>
+              <a:rPr lang="en-US" smtClean="0"/>
               <a:t>Click to edit Master text styles</a:t>
             </a:r>
           </a:p>
           <a:p>
             <a:pPr lvl="1"/>
             <a:r>
-              <a:rPr lang="en-US"/>
+              <a:rPr lang="en-US" smtClean="0"/>
               <a:t>Second level</a:t>
             </a:r>
           </a:p>
           <a:p>
             <a:pPr lvl="2"/>
             <a:r>
-              <a:rPr lang="en-US"/>
+              <a:rPr lang="en-US" smtClean="0"/>
               <a:t>Third level</a:t>
             </a:r>
           </a:p>
           <a:p>
             <a:pPr lvl="3"/>
             <a:r>
-              <a:rPr lang="en-US"/>
+              <a:rPr lang="en-US" smtClean="0"/>
               <a:t>Fourth level</a:t>
             </a:r>
           </a:p>
           <a:p>
             <a:pPr lvl="4"/>
             <a:r>
-              <a:rPr lang="en-US"/>
+              <a:rPr lang="en-US" smtClean="0"/>
               <a:t>Fifth level</a:t>
             </a:r>
+            <a:endParaRPr lang="en-US"/>
           </a:p>
         </p:txBody>
       </p:sp>
@@ -649,7 +639,7 @@
           <a:p>
             <a:fld id="{5BCAD085-E8A6-8845-BD4E-CB4CCA059FC4}" type="datetimeFigureOut">
               <a:rPr lang="en-US" smtClean="0"/>
-              <a:t>4/18/2026</a:t>
+              <a:t>1/27/13</a:t>
             </a:fld>
             <a:endParaRPr lang="en-US"/>
           </a:p>
@@ -691,7 +681,7 @@
           <a:p>
             <a:fld id="{C1FF6DA9-008F-8B48-92A6-B652298478BF}" type="slidenum">
               <a:rPr lang="en-US" smtClean="0"/>
-              <a:t>‹Nr.›</a:t>
+              <a:t>‹#›</a:t>
             </a:fld>
             <a:endParaRPr lang="en-US"/>
           </a:p>
@@ -743,9 +733,10 @@
           <a:lstStyle/>
           <a:p>
             <a:r>
-              <a:rPr lang="en-US"/>
+              <a:rPr lang="en-US" smtClean="0"/>
               <a:t>Click to edit Master title style</a:t>
             </a:r>
+            <a:endParaRPr lang="en-US"/>
           </a:p>
         </p:txBody>
       </p:sp>
@@ -766,37 +757,38 @@
           <a:p>
             <a:pPr lvl="0"/>
             <a:r>
-              <a:rPr lang="en-US"/>
+              <a:rPr lang="en-US" smtClean="0"/>
               <a:t>Click to edit Master text styles</a:t>
             </a:r>
           </a:p>
           <a:p>
             <a:pPr lvl="1"/>
             <a:r>
-              <a:rPr lang="en-US"/>
+              <a:rPr lang="en-US" smtClean="0"/>
               <a:t>Second level</a:t>
             </a:r>
           </a:p>
           <a:p>
             <a:pPr lvl="2"/>
             <a:r>
-              <a:rPr lang="en-US"/>
+              <a:rPr lang="en-US" smtClean="0"/>
               <a:t>Third level</a:t>
             </a:r>
           </a:p>
           <a:p>
             <a:pPr lvl="3"/>
             <a:r>
-              <a:rPr lang="en-US"/>
+              <a:rPr lang="en-US" smtClean="0"/>
               <a:t>Fourth level</a:t>
             </a:r>
           </a:p>
           <a:p>
             <a:pPr lvl="4"/>
             <a:r>
-              <a:rPr lang="en-US"/>
+              <a:rPr lang="en-US" smtClean="0"/>
               <a:t>Fifth level</a:t>
             </a:r>
+            <a:endParaRPr lang="en-US"/>
           </a:p>
         </p:txBody>
       </p:sp>
@@ -817,7 +809,7 @@
           <a:p>
             <a:fld id="{5BCAD085-E8A6-8845-BD4E-CB4CCA059FC4}" type="datetimeFigureOut">
               <a:rPr lang="en-US" smtClean="0"/>
-              <a:t>4/18/2026</a:t>
+              <a:t>1/27/13</a:t>
             </a:fld>
             <a:endParaRPr lang="en-US"/>
           </a:p>
@@ -859,7 +851,7 @@
           <a:p>
             <a:fld id="{C1FF6DA9-008F-8B48-92A6-B652298478BF}" type="slidenum">
               <a:rPr lang="en-US" smtClean="0"/>
-              <a:t>‹Nr.›</a:t>
+              <a:t>‹#›</a:t>
             </a:fld>
             <a:endParaRPr lang="en-US"/>
           </a:p>
@@ -920,9 +912,10 @@
           </a:lstStyle>
           <a:p>
             <a:r>
-              <a:rPr lang="en-US"/>
+              <a:rPr lang="en-US" smtClean="0"/>
               <a:t>Click to edit Master title style</a:t>
             </a:r>
+            <a:endParaRPr lang="en-US"/>
           </a:p>
         </p:txBody>
       </p:sp>
@@ -1039,7 +1032,7 @@
           <a:p>
             <a:pPr lvl="0"/>
             <a:r>
-              <a:rPr lang="en-US"/>
+              <a:rPr lang="en-US" smtClean="0"/>
               <a:t>Click to edit Master text styles</a:t>
             </a:r>
           </a:p>
@@ -1062,7 +1055,7 @@
           <a:p>
             <a:fld id="{5BCAD085-E8A6-8845-BD4E-CB4CCA059FC4}" type="datetimeFigureOut">
               <a:rPr lang="en-US" smtClean="0"/>
-              <a:t>4/18/2026</a:t>
+              <a:t>1/27/13</a:t>
             </a:fld>
             <a:endParaRPr lang="en-US"/>
           </a:p>
@@ -1104,7 +1097,7 @@
           <a:p>
             <a:fld id="{C1FF6DA9-008F-8B48-92A6-B652298478BF}" type="slidenum">
               <a:rPr lang="en-US" smtClean="0"/>
-              <a:t>‹Nr.›</a:t>
+              <a:t>‹#›</a:t>
             </a:fld>
             <a:endParaRPr lang="en-US"/>
           </a:p>
@@ -1156,9 +1149,10 @@
           <a:lstStyle/>
           <a:p>
             <a:r>
-              <a:rPr lang="en-US"/>
+              <a:rPr lang="en-US" smtClean="0"/>
               <a:t>Click to edit Master title style</a:t>
             </a:r>
+            <a:endParaRPr lang="en-US"/>
           </a:p>
         </p:txBody>
       </p:sp>
@@ -1212,37 +1206,38 @@
           <a:p>
             <a:pPr lvl="0"/>
             <a:r>
-              <a:rPr lang="en-US"/>
+              <a:rPr lang="en-US" smtClean="0"/>
               <a:t>Click to edit Master text styles</a:t>
             </a:r>
           </a:p>
           <a:p>
             <a:pPr lvl="1"/>
             <a:r>
-              <a:rPr lang="en-US"/>
+              <a:rPr lang="en-US" smtClean="0"/>
               <a:t>Second level</a:t>
             </a:r>
           </a:p>
           <a:p>
             <a:pPr lvl="2"/>
             <a:r>
-              <a:rPr lang="en-US"/>
+              <a:rPr lang="en-US" smtClean="0"/>
               <a:t>Third level</a:t>
             </a:r>
           </a:p>
           <a:p>
             <a:pPr lvl="3"/>
             <a:r>
-              <a:rPr lang="en-US"/>
+              <a:rPr lang="en-US" smtClean="0"/>
               <a:t>Fourth level</a:t>
             </a:r>
           </a:p>
           <a:p>
             <a:pPr lvl="4"/>
             <a:r>
-              <a:rPr lang="en-US"/>
+              <a:rPr lang="en-US" smtClean="0"/>
               <a:t>Fifth level</a:t>
             </a:r>
+            <a:endParaRPr lang="en-US"/>
           </a:p>
         </p:txBody>
       </p:sp>
@@ -1296,37 +1291,38 @@
           <a:p>
             <a:pPr lvl="0"/>
             <a:r>
-              <a:rPr lang="en-US"/>
+              <a:rPr lang="en-US" smtClean="0"/>
               <a:t>Click to edit Master text styles</a:t>
             </a:r>
           </a:p>
           <a:p>
             <a:pPr lvl="1"/>
             <a:r>
-              <a:rPr lang="en-US"/>
+              <a:rPr lang="en-US" smtClean="0"/>
               <a:t>Second level</a:t>
             </a:r>
           </a:p>
           <a:p>
             <a:pPr lvl="2"/>
             <a:r>
-              <a:rPr lang="en-US"/>
+              <a:rPr lang="en-US" smtClean="0"/>
               <a:t>Third level</a:t>
             </a:r>
           </a:p>
           <a:p>
             <a:pPr lvl="3"/>
             <a:r>
-              <a:rPr lang="en-US"/>
+              <a:rPr lang="en-US" smtClean="0"/>
               <a:t>Fourth level</a:t>
             </a:r>
           </a:p>
           <a:p>
             <a:pPr lvl="4"/>
             <a:r>
-              <a:rPr lang="en-US"/>
+              <a:rPr lang="en-US" smtClean="0"/>
               <a:t>Fifth level</a:t>
             </a:r>
+            <a:endParaRPr lang="en-US"/>
           </a:p>
         </p:txBody>
       </p:sp>
@@ -1347,7 +1343,7 @@
           <a:p>
             <a:fld id="{5BCAD085-E8A6-8845-BD4E-CB4CCA059FC4}" type="datetimeFigureOut">
               <a:rPr lang="en-US" smtClean="0"/>
-              <a:t>4/18/2026</a:t>
+              <a:t>1/27/13</a:t>
             </a:fld>
             <a:endParaRPr lang="en-US"/>
           </a:p>
@@ -1389,7 +1385,7 @@
           <a:p>
             <a:fld id="{C1FF6DA9-008F-8B48-92A6-B652298478BF}" type="slidenum">
               <a:rPr lang="en-US" smtClean="0"/>
-              <a:t>‹Nr.›</a:t>
+              <a:t>‹#›</a:t>
             </a:fld>
             <a:endParaRPr lang="en-US"/>
           </a:p>
@@ -1445,9 +1441,10 @@
           </a:lstStyle>
           <a:p>
             <a:r>
-              <a:rPr lang="en-US"/>
+              <a:rPr lang="en-US" smtClean="0"/>
               <a:t>Click to edit Master title style</a:t>
             </a:r>
+            <a:endParaRPr lang="en-US"/>
           </a:p>
         </p:txBody>
       </p:sp>
@@ -1510,7 +1507,7 @@
           <a:p>
             <a:pPr lvl="0"/>
             <a:r>
-              <a:rPr lang="en-US"/>
+              <a:rPr lang="en-US" smtClean="0"/>
               <a:t>Click to edit Master text styles</a:t>
             </a:r>
           </a:p>
@@ -1566,37 +1563,38 @@
           <a:p>
             <a:pPr lvl="0"/>
             <a:r>
-              <a:rPr lang="en-US"/>
+              <a:rPr lang="en-US" smtClean="0"/>
               <a:t>Click to edit Master text styles</a:t>
             </a:r>
           </a:p>
           <a:p>
             <a:pPr lvl="1"/>
             <a:r>
-              <a:rPr lang="en-US"/>
+              <a:rPr lang="en-US" smtClean="0"/>
               <a:t>Second level</a:t>
             </a:r>
           </a:p>
           <a:p>
             <a:pPr lvl="2"/>
             <a:r>
-              <a:rPr lang="en-US"/>
+              <a:rPr lang="en-US" smtClean="0"/>
               <a:t>Third level</a:t>
             </a:r>
           </a:p>
           <a:p>
             <a:pPr lvl="3"/>
             <a:r>
-              <a:rPr lang="en-US"/>
+              <a:rPr lang="en-US" smtClean="0"/>
               <a:t>Fourth level</a:t>
             </a:r>
           </a:p>
           <a:p>
             <a:pPr lvl="4"/>
             <a:r>
-              <a:rPr lang="en-US"/>
+              <a:rPr lang="en-US" smtClean="0"/>
               <a:t>Fifth level</a:t>
             </a:r>
+            <a:endParaRPr lang="en-US"/>
           </a:p>
         </p:txBody>
       </p:sp>
@@ -1659,7 +1657,7 @@
           <a:p>
             <a:pPr lvl="0"/>
             <a:r>
-              <a:rPr lang="en-US"/>
+              <a:rPr lang="en-US" smtClean="0"/>
               <a:t>Click to edit Master text styles</a:t>
             </a:r>
           </a:p>
@@ -1715,37 +1713,38 @@
           <a:p>
             <a:pPr lvl="0"/>
             <a:r>
-              <a:rPr lang="en-US"/>
+              <a:rPr lang="en-US" smtClean="0"/>
               <a:t>Click to edit Master text styles</a:t>
             </a:r>
           </a:p>
           <a:p>
             <a:pPr lvl="1"/>
             <a:r>
-              <a:rPr lang="en-US"/>
+              <a:rPr lang="en-US" smtClean="0"/>
               <a:t>Second level</a:t>
             </a:r>
           </a:p>
           <a:p>
             <a:pPr lvl="2"/>
             <a:r>
-              <a:rPr lang="en-US"/>
+              <a:rPr lang="en-US" smtClean="0"/>
               <a:t>Third level</a:t>
             </a:r>
           </a:p>
           <a:p>
             <a:pPr lvl="3"/>
             <a:r>
-              <a:rPr lang="en-US"/>
+              <a:rPr lang="en-US" smtClean="0"/>
               <a:t>Fourth level</a:t>
             </a:r>
           </a:p>
           <a:p>
             <a:pPr lvl="4"/>
             <a:r>
-              <a:rPr lang="en-US"/>
+              <a:rPr lang="en-US" smtClean="0"/>
               <a:t>Fifth level</a:t>
             </a:r>
+            <a:endParaRPr lang="en-US"/>
           </a:p>
         </p:txBody>
       </p:sp>
@@ -1766,7 +1765,7 @@
           <a:p>
             <a:fld id="{5BCAD085-E8A6-8845-BD4E-CB4CCA059FC4}" type="datetimeFigureOut">
               <a:rPr lang="en-US" smtClean="0"/>
-              <a:t>4/18/2026</a:t>
+              <a:t>1/27/13</a:t>
             </a:fld>
             <a:endParaRPr lang="en-US"/>
           </a:p>
@@ -1808,7 +1807,7 @@
           <a:p>
             <a:fld id="{C1FF6DA9-008F-8B48-92A6-B652298478BF}" type="slidenum">
               <a:rPr lang="en-US" smtClean="0"/>
-              <a:t>‹Nr.›</a:t>
+              <a:t>‹#›</a:t>
             </a:fld>
             <a:endParaRPr lang="en-US"/>
           </a:p>
@@ -1860,9 +1859,10 @@
           <a:lstStyle/>
           <a:p>
             <a:r>
-              <a:rPr lang="en-US"/>
+              <a:rPr lang="en-US" smtClean="0"/>
               <a:t>Click to edit Master title style</a:t>
             </a:r>
+            <a:endParaRPr lang="en-US"/>
           </a:p>
         </p:txBody>
       </p:sp>
@@ -1883,7 +1883,7 @@
           <a:p>
             <a:fld id="{5BCAD085-E8A6-8845-BD4E-CB4CCA059FC4}" type="datetimeFigureOut">
               <a:rPr lang="en-US" smtClean="0"/>
-              <a:t>4/18/2026</a:t>
+              <a:t>1/27/13</a:t>
             </a:fld>
             <a:endParaRPr lang="en-US"/>
           </a:p>
@@ -1925,7 +1925,7 @@
           <a:p>
             <a:fld id="{C1FF6DA9-008F-8B48-92A6-B652298478BF}" type="slidenum">
               <a:rPr lang="en-US" smtClean="0"/>
-              <a:t>‹Nr.›</a:t>
+              <a:t>‹#›</a:t>
             </a:fld>
             <a:endParaRPr lang="en-US"/>
           </a:p>
@@ -1978,7 +1978,7 @@
           <a:p>
             <a:fld id="{5BCAD085-E8A6-8845-BD4E-CB4CCA059FC4}" type="datetimeFigureOut">
               <a:rPr lang="en-US" smtClean="0"/>
-              <a:t>4/18/2026</a:t>
+              <a:t>1/27/13</a:t>
             </a:fld>
             <a:endParaRPr lang="en-US"/>
           </a:p>
@@ -2020,7 +2020,7 @@
           <a:p>
             <a:fld id="{C1FF6DA9-008F-8B48-92A6-B652298478BF}" type="slidenum">
               <a:rPr lang="en-US" smtClean="0"/>
-              <a:t>‹Nr.›</a:t>
+              <a:t>‹#›</a:t>
             </a:fld>
             <a:endParaRPr lang="en-US"/>
           </a:p>
@@ -2081,9 +2081,10 @@
           </a:lstStyle>
           <a:p>
             <a:r>
-              <a:rPr lang="en-US"/>
+              <a:rPr lang="en-US" smtClean="0"/>
               <a:t>Click to edit Master title style</a:t>
             </a:r>
+            <a:endParaRPr lang="en-US"/>
           </a:p>
         </p:txBody>
       </p:sp>
@@ -2137,37 +2138,38 @@
           <a:p>
             <a:pPr lvl="0"/>
             <a:r>
-              <a:rPr lang="en-US"/>
+              <a:rPr lang="en-US" smtClean="0"/>
               <a:t>Click to edit Master text styles</a:t>
             </a:r>
           </a:p>
           <a:p>
             <a:pPr lvl="1"/>
             <a:r>
-              <a:rPr lang="en-US"/>
+              <a:rPr lang="en-US" smtClean="0"/>
               <a:t>Second level</a:t>
             </a:r>
           </a:p>
           <a:p>
             <a:pPr lvl="2"/>
             <a:r>
-              <a:rPr lang="en-US"/>
+              <a:rPr lang="en-US" smtClean="0"/>
               <a:t>Third level</a:t>
             </a:r>
           </a:p>
           <a:p>
             <a:pPr lvl="3"/>
             <a:r>
-              <a:rPr lang="en-US"/>
+              <a:rPr lang="en-US" smtClean="0"/>
               <a:t>Fourth level</a:t>
             </a:r>
           </a:p>
           <a:p>
             <a:pPr lvl="4"/>
             <a:r>
-              <a:rPr lang="en-US"/>
+              <a:rPr lang="en-US" smtClean="0"/>
               <a:t>Fifth level</a:t>
             </a:r>
+            <a:endParaRPr lang="en-US"/>
           </a:p>
         </p:txBody>
       </p:sp>
@@ -2230,7 +2232,7 @@
           <a:p>
             <a:pPr lvl="0"/>
             <a:r>
-              <a:rPr lang="en-US"/>
+              <a:rPr lang="en-US" smtClean="0"/>
               <a:t>Click to edit Master text styles</a:t>
             </a:r>
           </a:p>
@@ -2253,7 +2255,7 @@
           <a:p>
             <a:fld id="{5BCAD085-E8A6-8845-BD4E-CB4CCA059FC4}" type="datetimeFigureOut">
               <a:rPr lang="en-US" smtClean="0"/>
-              <a:t>4/18/2026</a:t>
+              <a:t>1/27/13</a:t>
             </a:fld>
             <a:endParaRPr lang="en-US"/>
           </a:p>
@@ -2295,7 +2297,7 @@
           <a:p>
             <a:fld id="{C1FF6DA9-008F-8B48-92A6-B652298478BF}" type="slidenum">
               <a:rPr lang="en-US" smtClean="0"/>
-              <a:t>‹Nr.›</a:t>
+              <a:t>‹#›</a:t>
             </a:fld>
             <a:endParaRPr lang="en-US"/>
           </a:p>
@@ -2356,9 +2358,10 @@
           </a:lstStyle>
           <a:p>
             <a:r>
-              <a:rPr lang="en-US"/>
+              <a:rPr lang="en-US" smtClean="0"/>
               <a:t>Click to edit Master title style</a:t>
             </a:r>
+            <a:endParaRPr lang="en-US"/>
           </a:p>
         </p:txBody>
       </p:sp>
@@ -2482,7 +2485,7 @@
           <a:p>
             <a:pPr lvl="0"/>
             <a:r>
-              <a:rPr lang="en-US"/>
+              <a:rPr lang="en-US" smtClean="0"/>
               <a:t>Click to edit Master text styles</a:t>
             </a:r>
           </a:p>
@@ -2505,7 +2508,7 @@
           <a:p>
             <a:fld id="{5BCAD085-E8A6-8845-BD4E-CB4CCA059FC4}" type="datetimeFigureOut">
               <a:rPr lang="en-US" smtClean="0"/>
-              <a:t>4/18/2026</a:t>
+              <a:t>1/27/13</a:t>
             </a:fld>
             <a:endParaRPr lang="en-US"/>
           </a:p>
@@ -2547,7 +2550,7 @@
           <a:p>
             <a:fld id="{C1FF6DA9-008F-8B48-92A6-B652298478BF}" type="slidenum">
               <a:rPr lang="en-US" smtClean="0"/>
-              <a:t>‹Nr.›</a:t>
+              <a:t>‹#›</a:t>
             </a:fld>
             <a:endParaRPr lang="en-US"/>
           </a:p>
@@ -2614,9 +2617,10 @@
           <a:lstStyle/>
           <a:p>
             <a:r>
-              <a:rPr lang="en-US"/>
+              <a:rPr lang="en-US" smtClean="0"/>
               <a:t>Click to edit Master title style</a:t>
             </a:r>
+            <a:endParaRPr lang="en-US"/>
           </a:p>
         </p:txBody>
       </p:sp>
@@ -2647,37 +2651,38 @@
           <a:p>
             <a:pPr lvl="0"/>
             <a:r>
-              <a:rPr lang="en-US"/>
+              <a:rPr lang="en-US" smtClean="0"/>
               <a:t>Click to edit Master text styles</a:t>
             </a:r>
           </a:p>
           <a:p>
             <a:pPr lvl="1"/>
             <a:r>
-              <a:rPr lang="en-US"/>
+              <a:rPr lang="en-US" smtClean="0"/>
               <a:t>Second level</a:t>
             </a:r>
           </a:p>
           <a:p>
             <a:pPr lvl="2"/>
             <a:r>
-              <a:rPr lang="en-US"/>
+              <a:rPr lang="en-US" smtClean="0"/>
               <a:t>Third level</a:t>
             </a:r>
           </a:p>
           <a:p>
             <a:pPr lvl="3"/>
             <a:r>
-              <a:rPr lang="en-US"/>
+              <a:rPr lang="en-US" smtClean="0"/>
               <a:t>Fourth level</a:t>
             </a:r>
           </a:p>
           <a:p>
             <a:pPr lvl="4"/>
             <a:r>
-              <a:rPr lang="en-US"/>
+              <a:rPr lang="en-US" smtClean="0"/>
               <a:t>Fifth level</a:t>
             </a:r>
+            <a:endParaRPr lang="en-US"/>
           </a:p>
         </p:txBody>
       </p:sp>
@@ -2716,7 +2721,7 @@
           <a:p>
             <a:fld id="{5BCAD085-E8A6-8845-BD4E-CB4CCA059FC4}" type="datetimeFigureOut">
               <a:rPr lang="en-US" smtClean="0"/>
-              <a:t>4/18/2026</a:t>
+              <a:t>1/27/13</a:t>
             </a:fld>
             <a:endParaRPr lang="en-US"/>
           </a:p>
@@ -2794,7 +2799,7 @@
           <a:p>
             <a:fld id="{C1FF6DA9-008F-8B48-92A6-B652298478BF}" type="slidenum">
               <a:rPr lang="en-US" smtClean="0"/>
-              <a:t>‹Nr.›</a:t>
+              <a:t>‹#›</a:t>
             </a:fld>
             <a:endParaRPr lang="en-US"/>
           </a:p>
@@ -3075,7 +3080,7 @@
 </file>
 
 <file path=ppt/slides/slide1.xml><?xml version="1.0" encoding="utf-8"?>
-<p:sld xmlns:a="http://schemas.openxmlformats.org/drawingml/2006/main" xmlns:r="http://schemas.openxmlformats.org/officeDocument/2006/relationships" xmlns:p="http://schemas.openxmlformats.org/presentationml/2006/main">
+<p:sld xmlns:a="http://schemas.openxmlformats.org/drawingml/2006/main" xmlns:p="http://schemas.openxmlformats.org/presentationml/2006/main" xmlns:r="http://schemas.openxmlformats.org/officeDocument/2006/relationships">
   <p:cSld>
     <p:spTree>
       <p:nvGrpSpPr>
@@ -3083,14 +3088,7 @@
         <p:cNvGrpSpPr/>
         <p:nvPr/>
       </p:nvGrpSpPr>
-      <p:grpSpPr>
-        <a:xfrm>
-          <a:off x="0" y="0"/>
-          <a:ext cx="0" cy="0"/>
-          <a:chOff x="0" y="0"/>
-          <a:chExt cx="0" cy="0"/>
-        </a:xfrm>
-      </p:grpSpPr>
+      <p:grpSpPr/>
       <p:sp>
         <p:nvSpPr>
           <p:cNvPr id="2" name="Title 1"/>
@@ -3107,22 +3105,8 @@
           <a:lstStyle/>
           <a:p>
             <a:r>
-              <a:rPr lang="de-DE" dirty="0"/>
-              <a:t>Title </a:t>
-            </a:r>
-            <a:r>
-              <a:rPr lang="de-DE" dirty="0" err="1"/>
-              <a:t>of</a:t>
-            </a:r>
-            <a:r>
-              <a:rPr lang="de-DE" dirty="0"/>
-              <a:t> a Demo </a:t>
-            </a:r>
-            <a:r>
-              <a:rPr lang="de-DE" dirty="0" err="1"/>
-              <a:t>Presentation</a:t>
-            </a:r>
-            <a:endParaRPr dirty="0"/>
+              <a:t>Two Content Presentation</a:t>
+            </a:r>
           </a:p>
         </p:txBody>
       </p:sp>
@@ -3142,14 +3126,8 @@
           <a:lstStyle/>
           <a:p>
             <a:r>
-              <a:rPr lang="en-US" dirty="0"/>
-              <a:t>Author, Date</a:t>
-            </a:r>
-            <a:r>
-              <a:rPr lang="en-US"/>
-              <a:t>, Institution</a:t>
-            </a:r>
-            <a:endParaRPr lang="en-US" dirty="0"/>
+              <a:t>Diese Testpräsentation prüft das 'Two Content' Layout. Dabei ist wichtig, dass beide Spalten als Layout Element korrekt in das Grid im Typst-Code extrahiert und gesetzt werden.</a:t>
+            </a:r>
           </a:p>
         </p:txBody>
       </p:sp>
@@ -3162,7 +3140,7 @@
 </file>
 
 <file path=ppt/slides/slide2.xml><?xml version="1.0" encoding="utf-8"?>
-<p:sld xmlns:a="http://schemas.openxmlformats.org/drawingml/2006/main" xmlns:r="http://schemas.openxmlformats.org/officeDocument/2006/relationships" xmlns:p="http://schemas.openxmlformats.org/presentationml/2006/main">
+<p:sld xmlns:a="http://schemas.openxmlformats.org/drawingml/2006/main" xmlns:p="http://schemas.openxmlformats.org/presentationml/2006/main" xmlns:r="http://schemas.openxmlformats.org/officeDocument/2006/relationships">
   <p:cSld>
     <p:spTree>
       <p:nvGrpSpPr>
@@ -3170,14 +3148,7 @@
         <p:cNvGrpSpPr/>
         <p:nvPr/>
       </p:nvGrpSpPr>
-      <p:grpSpPr>
-        <a:xfrm>
-          <a:off x="0" y="0"/>
-          <a:ext cx="0" cy="0"/>
-          <a:chOff x="0" y="0"/>
-          <a:chExt cx="0" cy="0"/>
-        </a:xfrm>
-      </p:grpSpPr>
+      <p:grpSpPr/>
       <p:sp>
         <p:nvSpPr>
           <p:cNvPr id="2" name="Title 1"/>
@@ -3206,16 +3177,22 @@
             <a:spLocks noGrp="1"/>
           </p:cNvSpPr>
           <p:nvPr>
-            <p:ph sz="half" idx="1"/>
-          </p:nvPr>
-        </p:nvSpPr>
-        <p:spPr/>
-        <p:txBody>
-          <a:bodyPr/>
-          <a:lstStyle/>
-          <a:p>
-            <a:r>
-              <a:t>Left content block</a:t>
+            <p:ph idx="1" sz="half"/>
+          </p:nvPr>
+        </p:nvSpPr>
+        <p:spPr/>
+        <p:txBody>
+          <a:bodyPr/>
+          <a:lstStyle/>
+          <a:p>
+            <a:r>
+              <a:t>[Two content layout, left block.]</a:t>
+            </a:r>
+          </a:p>
+          <a:p/>
+          <a:p>
+            <a:r>
+              <a:t>Lorem ipsum dolor sit amet, consectetur adipiscing elit. Aenean commodo ligula eget dolor. Aenean massa.</a:t>
             </a:r>
           </a:p>
         </p:txBody>
@@ -3227,16 +3204,22 @@
             <a:spLocks noGrp="1"/>
           </p:cNvSpPr>
           <p:nvPr>
-            <p:ph sz="half" idx="2"/>
-          </p:nvPr>
-        </p:nvSpPr>
-        <p:spPr/>
-        <p:txBody>
-          <a:bodyPr/>
-          <a:lstStyle/>
-          <a:p>
-            <a:r>
-              <a:t>Right content block</a:t>
+            <p:ph idx="2" sz="half"/>
+          </p:nvPr>
+        </p:nvSpPr>
+        <p:spPr/>
+        <p:txBody>
+          <a:bodyPr/>
+          <a:lstStyle/>
+          <a:p>
+            <a:r>
+              <a:t>[Two content layout, right block.]</a:t>
+            </a:r>
+          </a:p>
+          <a:p/>
+          <a:p>
+            <a:r>
+              <a:t>Lorem ipsum dolor sit amet, consectetur adipiscing elit. Aenean commodo ligula eget dolor. Aenean massa.</a:t>
             </a:r>
           </a:p>
         </p:txBody>

</xml_diff>